<commit_message>
S4_Projektbericht: data for pictures in gitignore
</commit_message>
<xml_diff>
--- a/Projektbericht/abbildungen/systemskizzen_layout_v02.pptx
+++ b/Projektbericht/abbildungen/systemskizzen_layout_v02.pptx
@@ -108,6 +108,11 @@
       </a:defRPr>
     </a:lvl9pPr>
   </p:defaultTextStyle>
+  <p:extLst>
+    <p:ext uri="{EFAFB233-063F-42B5-8137-9DF3F51BA10A}">
+      <p15:sldGuideLst xmlns:p15="http://schemas.microsoft.com/office/powerpoint/2012/main"/>
+    </p:ext>
+  </p:extLst>
 </p:presentation>
 </file>
 
@@ -115,33 +120,401 @@
 <pc:chgInfo xmlns:a="http://schemas.openxmlformats.org/drawingml/2006/main" xmlns:r="http://schemas.openxmlformats.org/officeDocument/2006/relationships" xmlns:ac="http://schemas.microsoft.com/office/drawing/2013/main/command" xmlns:pc="http://schemas.microsoft.com/office/powerpoint/2013/main/command">
   <pc:docChgLst>
     <pc:chgData name="Tobias Unger" userId="0a5458e38b5f4a0f" providerId="LiveId" clId="{5C6CAE59-BAC7-4E9C-B1A6-AA8C1CFC41BD}"/>
-    <pc:docChg chg="custSel modSld">
-      <pc:chgData name="Tobias Unger" userId="0a5458e38b5f4a0f" providerId="LiveId" clId="{5C6CAE59-BAC7-4E9C-B1A6-AA8C1CFC41BD}" dt="2026-09-30T13:13:09.774" v="369" actId="255"/>
+    <pc:docChg chg="undo custSel modSld">
+      <pc:chgData name="Tobias Unger" userId="0a5458e38b5f4a0f" providerId="LiveId" clId="{5C6CAE59-BAC7-4E9C-B1A6-AA8C1CFC41BD}" dt="2026-09-30T14:36:30.613" v="1347" actId="1035"/>
       <pc:docMkLst>
         <pc:docMk/>
       </pc:docMkLst>
-      <pc:sldChg chg="modSp mod">
-        <pc:chgData name="Tobias Unger" userId="0a5458e38b5f4a0f" providerId="LiveId" clId="{5C6CAE59-BAC7-4E9C-B1A6-AA8C1CFC41BD}" dt="2026-09-30T13:13:09.774" v="369" actId="255"/>
+      <pc:sldChg chg="addSp delSp modSp mod">
+        <pc:chgData name="Tobias Unger" userId="0a5458e38b5f4a0f" providerId="LiveId" clId="{5C6CAE59-BAC7-4E9C-B1A6-AA8C1CFC41BD}" dt="2026-09-30T14:14:46.296" v="1317" actId="1036"/>
         <pc:sldMkLst>
           <pc:docMk/>
           <pc:sldMk cId="1021586582" sldId="256"/>
         </pc:sldMkLst>
         <pc:spChg chg="mod">
-          <ac:chgData name="Tobias Unger" userId="0a5458e38b5f4a0f" providerId="LiveId" clId="{5C6CAE59-BAC7-4E9C-B1A6-AA8C1CFC41BD}" dt="2026-09-30T13:13:09.774" v="369" actId="255"/>
+          <ac:chgData name="Tobias Unger" userId="0a5458e38b5f4a0f" providerId="LiveId" clId="{5C6CAE59-BAC7-4E9C-B1A6-AA8C1CFC41BD}" dt="2026-09-30T14:00:48.786" v="1012" actId="27636"/>
+          <ac:spMkLst>
+            <pc:docMk/>
+            <pc:sldMk cId="1021586582" sldId="256"/>
+            <ac:spMk id="2" creationId="{D520012F-42E0-4875-86F1-0CB0A5068B79}"/>
+          </ac:spMkLst>
+        </pc:spChg>
+        <pc:spChg chg="mod">
+          <ac:chgData name="Tobias Unger" userId="0a5458e38b5f4a0f" providerId="LiveId" clId="{5C6CAE59-BAC7-4E9C-B1A6-AA8C1CFC41BD}" dt="2026-09-30T14:00:10.031" v="930" actId="1076"/>
+          <ac:spMkLst>
+            <pc:docMk/>
+            <pc:sldMk cId="1021586582" sldId="256"/>
+            <ac:spMk id="3" creationId="{9C899BA4-EC78-480D-9E8F-C2FA9CD9A07A}"/>
+          </ac:spMkLst>
+        </pc:spChg>
+        <pc:spChg chg="mod">
+          <ac:chgData name="Tobias Unger" userId="0a5458e38b5f4a0f" providerId="LiveId" clId="{5C6CAE59-BAC7-4E9C-B1A6-AA8C1CFC41BD}" dt="2026-09-30T14:14:40.620" v="1287" actId="1035"/>
+          <ac:spMkLst>
+            <pc:docMk/>
+            <pc:sldMk cId="1021586582" sldId="256"/>
+            <ac:spMk id="4" creationId="{A722486D-4E28-4D5D-BCA6-FDF7C1BCB7DB}"/>
+          </ac:spMkLst>
+        </pc:spChg>
+        <pc:spChg chg="mod">
+          <ac:chgData name="Tobias Unger" userId="0a5458e38b5f4a0f" providerId="LiveId" clId="{5C6CAE59-BAC7-4E9C-B1A6-AA8C1CFC41BD}" dt="2026-09-30T14:14:40.620" v="1287" actId="1035"/>
+          <ac:spMkLst>
+            <pc:docMk/>
+            <pc:sldMk cId="1021586582" sldId="256"/>
+            <ac:spMk id="6" creationId="{44052241-64B2-4ACD-B038-0D9BB87B9D97}"/>
+          </ac:spMkLst>
+        </pc:spChg>
+        <pc:spChg chg="mod">
+          <ac:chgData name="Tobias Unger" userId="0a5458e38b5f4a0f" providerId="LiveId" clId="{5C6CAE59-BAC7-4E9C-B1A6-AA8C1CFC41BD}" dt="2026-09-30T14:14:40.620" v="1287" actId="1035"/>
+          <ac:spMkLst>
+            <pc:docMk/>
+            <pc:sldMk cId="1021586582" sldId="256"/>
+            <ac:spMk id="7" creationId="{18C006F9-2211-4E46-A5A5-9B7842EA0FB2}"/>
+          </ac:spMkLst>
+        </pc:spChg>
+        <pc:spChg chg="mod">
+          <ac:chgData name="Tobias Unger" userId="0a5458e38b5f4a0f" providerId="LiveId" clId="{5C6CAE59-BAC7-4E9C-B1A6-AA8C1CFC41BD}" dt="2026-09-30T13:42:54.453" v="668" actId="1076"/>
+          <ac:spMkLst>
+            <pc:docMk/>
+            <pc:sldMk cId="1021586582" sldId="256"/>
+            <ac:spMk id="8" creationId="{9910BF13-8933-42F4-94EF-73AF0584D290}"/>
+          </ac:spMkLst>
+        </pc:spChg>
+        <pc:spChg chg="del mod">
+          <ac:chgData name="Tobias Unger" userId="0a5458e38b5f4a0f" providerId="LiveId" clId="{5C6CAE59-BAC7-4E9C-B1A6-AA8C1CFC41BD}" dt="2026-09-30T13:42:58.944" v="670" actId="478"/>
+          <ac:spMkLst>
+            <pc:docMk/>
+            <pc:sldMk cId="1021586582" sldId="256"/>
+            <ac:spMk id="9" creationId="{A4B5AB90-A8BF-4E36-AC6F-1FA54F2E7A11}"/>
+          </ac:spMkLst>
+        </pc:spChg>
+        <pc:spChg chg="mod">
+          <ac:chgData name="Tobias Unger" userId="0a5458e38b5f4a0f" providerId="LiveId" clId="{5C6CAE59-BAC7-4E9C-B1A6-AA8C1CFC41BD}" dt="2026-09-30T14:14:40.620" v="1287" actId="1035"/>
+          <ac:spMkLst>
+            <pc:docMk/>
+            <pc:sldMk cId="1021586582" sldId="256"/>
+            <ac:spMk id="10" creationId="{0481AB1A-865B-4612-B957-1F8C3204C392}"/>
+          </ac:spMkLst>
+        </pc:spChg>
+        <pc:spChg chg="mod">
+          <ac:chgData name="Tobias Unger" userId="0a5458e38b5f4a0f" providerId="LiveId" clId="{5C6CAE59-BAC7-4E9C-B1A6-AA8C1CFC41BD}" dt="2026-09-30T14:14:40.620" v="1287" actId="1035"/>
+          <ac:spMkLst>
+            <pc:docMk/>
+            <pc:sldMk cId="1021586582" sldId="256"/>
+            <ac:spMk id="11" creationId="{CBEF7EA2-0B71-4535-ADD3-82F6E9B85864}"/>
+          </ac:spMkLst>
+        </pc:spChg>
+        <pc:spChg chg="mod">
+          <ac:chgData name="Tobias Unger" userId="0a5458e38b5f4a0f" providerId="LiveId" clId="{5C6CAE59-BAC7-4E9C-B1A6-AA8C1CFC41BD}" dt="2026-09-30T14:14:40.620" v="1287" actId="1035"/>
+          <ac:spMkLst>
+            <pc:docMk/>
+            <pc:sldMk cId="1021586582" sldId="256"/>
+            <ac:spMk id="12" creationId="{A8EBAD4A-4B99-4A76-BBF3-153335586177}"/>
+          </ac:spMkLst>
+        </pc:spChg>
+        <pc:spChg chg="mod">
+          <ac:chgData name="Tobias Unger" userId="0a5458e38b5f4a0f" providerId="LiveId" clId="{5C6CAE59-BAC7-4E9C-B1A6-AA8C1CFC41BD}" dt="2026-09-30T14:14:40.620" v="1287" actId="1035"/>
+          <ac:spMkLst>
+            <pc:docMk/>
+            <pc:sldMk cId="1021586582" sldId="256"/>
+            <ac:spMk id="13" creationId="{4652F6FE-6131-4B29-92B9-D74019DBA6AF}"/>
+          </ac:spMkLst>
+        </pc:spChg>
+        <pc:spChg chg="mod">
+          <ac:chgData name="Tobias Unger" userId="0a5458e38b5f4a0f" providerId="LiveId" clId="{5C6CAE59-BAC7-4E9C-B1A6-AA8C1CFC41BD}" dt="2026-09-30T14:14:40.620" v="1287" actId="1035"/>
+          <ac:spMkLst>
+            <pc:docMk/>
+            <pc:sldMk cId="1021586582" sldId="256"/>
+            <ac:spMk id="14" creationId="{8E875ED1-4C7A-49F0-8291-C9A12C02D914}"/>
+          </ac:spMkLst>
+        </pc:spChg>
+        <pc:spChg chg="mod">
+          <ac:chgData name="Tobias Unger" userId="0a5458e38b5f4a0f" providerId="LiveId" clId="{5C6CAE59-BAC7-4E9C-B1A6-AA8C1CFC41BD}" dt="2026-09-30T14:14:40.620" v="1287" actId="1035"/>
+          <ac:spMkLst>
+            <pc:docMk/>
+            <pc:sldMk cId="1021586582" sldId="256"/>
+            <ac:spMk id="16" creationId="{D67288C0-99B2-4338-8094-369D38AA5210}"/>
+          </ac:spMkLst>
+        </pc:spChg>
+        <pc:spChg chg="mod">
+          <ac:chgData name="Tobias Unger" userId="0a5458e38b5f4a0f" providerId="LiveId" clId="{5C6CAE59-BAC7-4E9C-B1A6-AA8C1CFC41BD}" dt="2026-09-30T13:58:39.216" v="902" actId="1037"/>
+          <ac:spMkLst>
+            <pc:docMk/>
+            <pc:sldMk cId="1021586582" sldId="256"/>
+            <ac:spMk id="17" creationId="{16F09412-6B6B-4CEA-93FE-FF0B528F5D95}"/>
+          </ac:spMkLst>
+        </pc:spChg>
+        <pc:spChg chg="mod">
+          <ac:chgData name="Tobias Unger" userId="0a5458e38b5f4a0f" providerId="LiveId" clId="{5C6CAE59-BAC7-4E9C-B1A6-AA8C1CFC41BD}" dt="2026-09-30T13:59:01.783" v="907" actId="1076"/>
+          <ac:spMkLst>
+            <pc:docMk/>
+            <pc:sldMk cId="1021586582" sldId="256"/>
+            <ac:spMk id="18" creationId="{4EB80D1B-3B57-4BAA-B983-7F9B345D4181}"/>
+          </ac:spMkLst>
+        </pc:spChg>
+        <pc:spChg chg="mod">
+          <ac:chgData name="Tobias Unger" userId="0a5458e38b5f4a0f" providerId="LiveId" clId="{5C6CAE59-BAC7-4E9C-B1A6-AA8C1CFC41BD}" dt="2026-09-30T13:43:12.489" v="682" actId="1035"/>
+          <ac:spMkLst>
+            <pc:docMk/>
+            <pc:sldMk cId="1021586582" sldId="256"/>
+            <ac:spMk id="20" creationId="{5912AA45-AA4F-4C99-9175-4BD03851504B}"/>
+          </ac:spMkLst>
+        </pc:spChg>
+        <pc:spChg chg="mod">
+          <ac:chgData name="Tobias Unger" userId="0a5458e38b5f4a0f" providerId="LiveId" clId="{5C6CAE59-BAC7-4E9C-B1A6-AA8C1CFC41BD}" dt="2026-09-30T14:14:20.632" v="1260" actId="1076"/>
+          <ac:spMkLst>
+            <pc:docMk/>
+            <pc:sldMk cId="1021586582" sldId="256"/>
+            <ac:spMk id="21" creationId="{BACB867F-6734-4A87-8F8B-8E6BC22A9EB0}"/>
+          </ac:spMkLst>
+        </pc:spChg>
+        <pc:spChg chg="mod">
+          <ac:chgData name="Tobias Unger" userId="0a5458e38b5f4a0f" providerId="LiveId" clId="{5C6CAE59-BAC7-4E9C-B1A6-AA8C1CFC41BD}" dt="2026-09-30T14:14:20.632" v="1260" actId="1076"/>
+          <ac:spMkLst>
+            <pc:docMk/>
+            <pc:sldMk cId="1021586582" sldId="256"/>
+            <ac:spMk id="22" creationId="{A12DDF78-AA6B-4EB0-927E-89B8013E762B}"/>
+          </ac:spMkLst>
+        </pc:spChg>
+        <pc:spChg chg="mod">
+          <ac:chgData name="Tobias Unger" userId="0a5458e38b5f4a0f" providerId="LiveId" clId="{5C6CAE59-BAC7-4E9C-B1A6-AA8C1CFC41BD}" dt="2026-09-30T14:14:20.632" v="1260" actId="1076"/>
+          <ac:spMkLst>
+            <pc:docMk/>
+            <pc:sldMk cId="1021586582" sldId="256"/>
+            <ac:spMk id="23" creationId="{8CF864C3-9561-42E1-8B4D-098E607C8519}"/>
+          </ac:spMkLst>
+        </pc:spChg>
+        <pc:spChg chg="mod">
+          <ac:chgData name="Tobias Unger" userId="0a5458e38b5f4a0f" providerId="LiveId" clId="{5C6CAE59-BAC7-4E9C-B1A6-AA8C1CFC41BD}" dt="2026-09-30T14:14:20.632" v="1260" actId="1076"/>
+          <ac:spMkLst>
+            <pc:docMk/>
+            <pc:sldMk cId="1021586582" sldId="256"/>
+            <ac:spMk id="24" creationId="{6B31B82B-EB40-4094-914F-4E3E7A74AF0C}"/>
+          </ac:spMkLst>
+        </pc:spChg>
+        <pc:spChg chg="mod">
+          <ac:chgData name="Tobias Unger" userId="0a5458e38b5f4a0f" providerId="LiveId" clId="{5C6CAE59-BAC7-4E9C-B1A6-AA8C1CFC41BD}" dt="2026-09-30T14:14:20.632" v="1260" actId="1076"/>
+          <ac:spMkLst>
+            <pc:docMk/>
+            <pc:sldMk cId="1021586582" sldId="256"/>
+            <ac:spMk id="25" creationId="{FF714F3F-A5E0-489E-A3B9-8354E819E072}"/>
+          </ac:spMkLst>
+        </pc:spChg>
+        <pc:spChg chg="mod">
+          <ac:chgData name="Tobias Unger" userId="0a5458e38b5f4a0f" providerId="LiveId" clId="{5C6CAE59-BAC7-4E9C-B1A6-AA8C1CFC41BD}" dt="2026-09-30T14:14:20.632" v="1260" actId="1076"/>
+          <ac:spMkLst>
+            <pc:docMk/>
+            <pc:sldMk cId="1021586582" sldId="256"/>
+            <ac:spMk id="26" creationId="{6F7BEE2A-4B96-43D4-9E09-EA2D77AC7FFD}"/>
+          </ac:spMkLst>
+        </pc:spChg>
+        <pc:spChg chg="mod">
+          <ac:chgData name="Tobias Unger" userId="0a5458e38b5f4a0f" providerId="LiveId" clId="{5C6CAE59-BAC7-4E9C-B1A6-AA8C1CFC41BD}" dt="2026-09-30T14:14:20.632" v="1260" actId="1076"/>
+          <ac:spMkLst>
+            <pc:docMk/>
+            <pc:sldMk cId="1021586582" sldId="256"/>
+            <ac:spMk id="27" creationId="{1B6482C7-7CA6-456C-AED0-6485B63DA147}"/>
+          </ac:spMkLst>
+        </pc:spChg>
+        <pc:spChg chg="mod">
+          <ac:chgData name="Tobias Unger" userId="0a5458e38b5f4a0f" providerId="LiveId" clId="{5C6CAE59-BAC7-4E9C-B1A6-AA8C1CFC41BD}" dt="2026-09-30T14:14:20.632" v="1260" actId="1076"/>
           <ac:spMkLst>
             <pc:docMk/>
             <pc:sldMk cId="1021586582" sldId="256"/>
             <ac:spMk id="28" creationId="{DB93E5B2-31C5-44B6-8440-3041A2B9878F}"/>
           </ac:spMkLst>
         </pc:spChg>
+        <pc:spChg chg="mod">
+          <ac:chgData name="Tobias Unger" userId="0a5458e38b5f4a0f" providerId="LiveId" clId="{5C6CAE59-BAC7-4E9C-B1A6-AA8C1CFC41BD}" dt="2026-09-30T14:14:20.632" v="1260" actId="1076"/>
+          <ac:spMkLst>
+            <pc:docMk/>
+            <pc:sldMk cId="1021586582" sldId="256"/>
+            <ac:spMk id="29" creationId="{D71AD7FE-2842-4291-B282-F9E751C0C557}"/>
+          </ac:spMkLst>
+        </pc:spChg>
+        <pc:spChg chg="mod">
+          <ac:chgData name="Tobias Unger" userId="0a5458e38b5f4a0f" providerId="LiveId" clId="{5C6CAE59-BAC7-4E9C-B1A6-AA8C1CFC41BD}" dt="2026-09-30T14:09:31.976" v="1193" actId="27636"/>
+          <ac:spMkLst>
+            <pc:docMk/>
+            <pc:sldMk cId="1021586582" sldId="256"/>
+            <ac:spMk id="30" creationId="{2158BA86-6D41-4413-A97F-4E1B5B47E628}"/>
+          </ac:spMkLst>
+        </pc:spChg>
+        <pc:spChg chg="mod">
+          <ac:chgData name="Tobias Unger" userId="0a5458e38b5f4a0f" providerId="LiveId" clId="{5C6CAE59-BAC7-4E9C-B1A6-AA8C1CFC41BD}" dt="2026-09-30T14:09:31.976" v="1192" actId="27636"/>
+          <ac:spMkLst>
+            <pc:docMk/>
+            <pc:sldMk cId="1021586582" sldId="256"/>
+            <ac:spMk id="32" creationId="{25AEE7E9-C98F-4796-8B47-DFB914AA672A}"/>
+          </ac:spMkLst>
+        </pc:spChg>
+        <pc:spChg chg="mod">
+          <ac:chgData name="Tobias Unger" userId="0a5458e38b5f4a0f" providerId="LiveId" clId="{5C6CAE59-BAC7-4E9C-B1A6-AA8C1CFC41BD}" dt="2026-09-30T14:00:48.784" v="1010" actId="27636"/>
+          <ac:spMkLst>
+            <pc:docMk/>
+            <pc:sldMk cId="1021586582" sldId="256"/>
+            <ac:spMk id="33" creationId="{48A718B7-3FC2-4EDF-B60C-889F47865DD3}"/>
+          </ac:spMkLst>
+        </pc:spChg>
+        <pc:spChg chg="mod">
+          <ac:chgData name="Tobias Unger" userId="0a5458e38b5f4a0f" providerId="LiveId" clId="{5C6CAE59-BAC7-4E9C-B1A6-AA8C1CFC41BD}" dt="2026-09-30T14:09:03.180" v="1184" actId="1036"/>
+          <ac:spMkLst>
+            <pc:docMk/>
+            <pc:sldMk cId="1021586582" sldId="256"/>
+            <ac:spMk id="34" creationId="{8E0183DC-75D5-4B9B-8F90-E79B84AF5802}"/>
+          </ac:spMkLst>
+        </pc:spChg>
+        <pc:spChg chg="mod">
+          <ac:chgData name="Tobias Unger" userId="0a5458e38b5f4a0f" providerId="LiveId" clId="{5C6CAE59-BAC7-4E9C-B1A6-AA8C1CFC41BD}" dt="2026-09-30T14:14:46.296" v="1317" actId="1036"/>
+          <ac:spMkLst>
+            <pc:docMk/>
+            <pc:sldMk cId="1021586582" sldId="256"/>
+            <ac:spMk id="35" creationId="{06EB5812-A397-4106-87EB-3F5304E7707B}"/>
+          </ac:spMkLst>
+        </pc:spChg>
+        <pc:spChg chg="mod">
+          <ac:chgData name="Tobias Unger" userId="0a5458e38b5f4a0f" providerId="LiveId" clId="{5C6CAE59-BAC7-4E9C-B1A6-AA8C1CFC41BD}" dt="2026-09-30T14:09:31.974" v="1191" actId="27636"/>
+          <ac:spMkLst>
+            <pc:docMk/>
+            <pc:sldMk cId="1021586582" sldId="256"/>
+            <ac:spMk id="36" creationId="{7314FD1F-175D-4EE2-93ED-E56A658ECAA5}"/>
+          </ac:spMkLst>
+        </pc:spChg>
+        <pc:spChg chg="mod">
+          <ac:chgData name="Tobias Unger" userId="0a5458e38b5f4a0f" providerId="LiveId" clId="{5C6CAE59-BAC7-4E9C-B1A6-AA8C1CFC41BD}" dt="2026-09-30T14:00:48.786" v="1013" actId="27636"/>
+          <ac:spMkLst>
+            <pc:docMk/>
+            <pc:sldMk cId="1021586582" sldId="256"/>
+            <ac:spMk id="37" creationId="{515E71D7-71AF-44F9-98C0-FDBAADAE911E}"/>
+          </ac:spMkLst>
+        </pc:spChg>
+        <pc:spChg chg="add mod">
+          <ac:chgData name="Tobias Unger" userId="0a5458e38b5f4a0f" providerId="LiveId" clId="{5C6CAE59-BAC7-4E9C-B1A6-AA8C1CFC41BD}" dt="2026-09-30T14:14:40.620" v="1287" actId="1035"/>
+          <ac:spMkLst>
+            <pc:docMk/>
+            <pc:sldMk cId="1021586582" sldId="256"/>
+            <ac:spMk id="39" creationId="{B617B894-729D-4FC4-36D0-EA47523A7F62}"/>
+          </ac:spMkLst>
+        </pc:spChg>
+        <pc:spChg chg="add mod">
+          <ac:chgData name="Tobias Unger" userId="0a5458e38b5f4a0f" providerId="LiveId" clId="{5C6CAE59-BAC7-4E9C-B1A6-AA8C1CFC41BD}" dt="2026-09-30T14:00:48.751" v="1009" actId="571"/>
+          <ac:spMkLst>
+            <pc:docMk/>
+            <pc:sldMk cId="1021586582" sldId="256"/>
+            <ac:spMk id="40" creationId="{91954000-D110-FE86-E9E6-FCA937AA15D3}"/>
+          </ac:spMkLst>
+        </pc:spChg>
+        <pc:spChg chg="add mod">
+          <ac:chgData name="Tobias Unger" userId="0a5458e38b5f4a0f" providerId="LiveId" clId="{5C6CAE59-BAC7-4E9C-B1A6-AA8C1CFC41BD}" dt="2026-09-30T14:00:48.751" v="1009" actId="571"/>
+          <ac:spMkLst>
+            <pc:docMk/>
+            <pc:sldMk cId="1021586582" sldId="256"/>
+            <ac:spMk id="41" creationId="{6B0F0D7C-D400-39D6-BA31-1557C5D310D8}"/>
+          </ac:spMkLst>
+        </pc:spChg>
+        <pc:spChg chg="add mod">
+          <ac:chgData name="Tobias Unger" userId="0a5458e38b5f4a0f" providerId="LiveId" clId="{5C6CAE59-BAC7-4E9C-B1A6-AA8C1CFC41BD}" dt="2026-09-30T14:12:06.376" v="1259" actId="571"/>
+          <ac:spMkLst>
+            <pc:docMk/>
+            <pc:sldMk cId="1021586582" sldId="256"/>
+            <ac:spMk id="48" creationId="{289C5C27-F2F2-E589-714E-681BBF1AEBC0}"/>
+          </ac:spMkLst>
+        </pc:spChg>
+        <pc:spChg chg="add mod">
+          <ac:chgData name="Tobias Unger" userId="0a5458e38b5f4a0f" providerId="LiveId" clId="{5C6CAE59-BAC7-4E9C-B1A6-AA8C1CFC41BD}" dt="2026-09-30T14:12:06.376" v="1259" actId="571"/>
+          <ac:spMkLst>
+            <pc:docMk/>
+            <pc:sldMk cId="1021586582" sldId="256"/>
+            <ac:spMk id="49" creationId="{3AC4EC99-69DF-92CA-A0A9-197F65BA4292}"/>
+          </ac:spMkLst>
+        </pc:spChg>
+        <pc:spChg chg="add mod">
+          <ac:chgData name="Tobias Unger" userId="0a5458e38b5f4a0f" providerId="LiveId" clId="{5C6CAE59-BAC7-4E9C-B1A6-AA8C1CFC41BD}" dt="2026-09-30T14:12:06.376" v="1259" actId="571"/>
+          <ac:spMkLst>
+            <pc:docMk/>
+            <pc:sldMk cId="1021586582" sldId="256"/>
+            <ac:spMk id="50" creationId="{40B9BCFB-D33D-DFE4-5C07-2DB2954B5E5C}"/>
+          </ac:spMkLst>
+        </pc:spChg>
+        <pc:spChg chg="add mod">
+          <ac:chgData name="Tobias Unger" userId="0a5458e38b5f4a0f" providerId="LiveId" clId="{5C6CAE59-BAC7-4E9C-B1A6-AA8C1CFC41BD}" dt="2026-09-30T14:12:06.376" v="1259" actId="571"/>
+          <ac:spMkLst>
+            <pc:docMk/>
+            <pc:sldMk cId="1021586582" sldId="256"/>
+            <ac:spMk id="51" creationId="{03C7074D-34F5-5B33-C71D-AED93A3A9B9C}"/>
+          </ac:spMkLst>
+        </pc:spChg>
+        <pc:spChg chg="add mod">
+          <ac:chgData name="Tobias Unger" userId="0a5458e38b5f4a0f" providerId="LiveId" clId="{5C6CAE59-BAC7-4E9C-B1A6-AA8C1CFC41BD}" dt="2026-09-30T14:12:06.376" v="1259" actId="571"/>
+          <ac:spMkLst>
+            <pc:docMk/>
+            <pc:sldMk cId="1021586582" sldId="256"/>
+            <ac:spMk id="52" creationId="{39FC7933-C8E6-7F63-4D3A-40CC62376A5F}"/>
+          </ac:spMkLst>
+        </pc:spChg>
+        <pc:spChg chg="add mod">
+          <ac:chgData name="Tobias Unger" userId="0a5458e38b5f4a0f" providerId="LiveId" clId="{5C6CAE59-BAC7-4E9C-B1A6-AA8C1CFC41BD}" dt="2026-09-30T14:12:06.376" v="1259" actId="571"/>
+          <ac:spMkLst>
+            <pc:docMk/>
+            <pc:sldMk cId="1021586582" sldId="256"/>
+            <ac:spMk id="53" creationId="{01513159-9BBB-876D-710A-B19BE4E354DA}"/>
+          </ac:spMkLst>
+        </pc:spChg>
+        <pc:spChg chg="add mod">
+          <ac:chgData name="Tobias Unger" userId="0a5458e38b5f4a0f" providerId="LiveId" clId="{5C6CAE59-BAC7-4E9C-B1A6-AA8C1CFC41BD}" dt="2026-09-30T14:12:06.376" v="1259" actId="571"/>
+          <ac:spMkLst>
+            <pc:docMk/>
+            <pc:sldMk cId="1021586582" sldId="256"/>
+            <ac:spMk id="54" creationId="{966197A7-85B4-76E8-0A45-23F6B92C8CF7}"/>
+          </ac:spMkLst>
+        </pc:spChg>
+        <pc:spChg chg="add mod">
+          <ac:chgData name="Tobias Unger" userId="0a5458e38b5f4a0f" providerId="LiveId" clId="{5C6CAE59-BAC7-4E9C-B1A6-AA8C1CFC41BD}" dt="2026-09-30T14:12:06.376" v="1259" actId="571"/>
+          <ac:spMkLst>
+            <pc:docMk/>
+            <pc:sldMk cId="1021586582" sldId="256"/>
+            <ac:spMk id="55" creationId="{A2EE1E9A-EE76-2A24-0967-C2878E18E56A}"/>
+          </ac:spMkLst>
+        </pc:spChg>
+        <pc:spChg chg="add mod">
+          <ac:chgData name="Tobias Unger" userId="0a5458e38b5f4a0f" providerId="LiveId" clId="{5C6CAE59-BAC7-4E9C-B1A6-AA8C1CFC41BD}" dt="2026-09-30T14:12:06.376" v="1259" actId="571"/>
+          <ac:spMkLst>
+            <pc:docMk/>
+            <pc:sldMk cId="1021586582" sldId="256"/>
+            <ac:spMk id="56" creationId="{B621E871-427F-9FEE-248E-229B1C1298A7}"/>
+          </ac:spMkLst>
+        </pc:spChg>
+        <pc:cxnChg chg="add mod">
+          <ac:chgData name="Tobias Unger" userId="0a5458e38b5f4a0f" providerId="LiveId" clId="{5C6CAE59-BAC7-4E9C-B1A6-AA8C1CFC41BD}" dt="2026-09-30T14:09:03.180" v="1184" actId="1036"/>
+          <ac:cxnSpMkLst>
+            <pc:docMk/>
+            <pc:sldMk cId="1021586582" sldId="256"/>
+            <ac:cxnSpMk id="43" creationId="{D44319DE-026A-0AF5-763D-791BBB12E0A5}"/>
+          </ac:cxnSpMkLst>
+        </pc:cxnChg>
+        <pc:cxnChg chg="add mod">
+          <ac:chgData name="Tobias Unger" userId="0a5458e38b5f4a0f" providerId="LiveId" clId="{5C6CAE59-BAC7-4E9C-B1A6-AA8C1CFC41BD}" dt="2026-09-30T14:09:52.044" v="1206" actId="1038"/>
+          <ac:cxnSpMkLst>
+            <pc:docMk/>
+            <pc:sldMk cId="1021586582" sldId="256"/>
+            <ac:cxnSpMk id="45" creationId="{35035BCB-D284-A973-89D3-919B2AA561F3}"/>
+          </ac:cxnSpMkLst>
+        </pc:cxnChg>
       </pc:sldChg>
       <pc:sldChg chg="addSp delSp modSp mod">
-        <pc:chgData name="Tobias Unger" userId="0a5458e38b5f4a0f" providerId="LiveId" clId="{5C6CAE59-BAC7-4E9C-B1A6-AA8C1CFC41BD}" dt="2026-09-30T13:05:58.077" v="361" actId="1038"/>
+        <pc:chgData name="Tobias Unger" userId="0a5458e38b5f4a0f" providerId="LiveId" clId="{5C6CAE59-BAC7-4E9C-B1A6-AA8C1CFC41BD}" dt="2026-09-30T14:36:30.613" v="1347" actId="1035"/>
         <pc:sldMkLst>
           <pc:docMk/>
           <pc:sldMk cId="936990828" sldId="257"/>
         </pc:sldMkLst>
         <pc:spChg chg="mod">
+          <ac:chgData name="Tobias Unger" userId="0a5458e38b5f4a0f" providerId="LiveId" clId="{5C6CAE59-BAC7-4E9C-B1A6-AA8C1CFC41BD}" dt="2026-09-30T14:00:48.836" v="1020" actId="27636"/>
+          <ac:spMkLst>
+            <pc:docMk/>
+            <pc:sldMk cId="936990828" sldId="257"/>
+            <ac:spMk id="2" creationId="{EB33F4EE-FB8E-4940-8DD7-BC14E093999F}"/>
+          </ac:spMkLst>
+        </pc:spChg>
+        <pc:spChg chg="mod">
           <ac:chgData name="Tobias Unger" userId="0a5458e38b5f4a0f" providerId="LiveId" clId="{5C6CAE59-BAC7-4E9C-B1A6-AA8C1CFC41BD}" dt="2026-09-30T13:05:58.077" v="361" actId="1038"/>
           <ac:spMkLst>
             <pc:docMk/>
@@ -157,6 +530,14 @@
             <ac:spMk id="8" creationId="{E0F41E24-7ABB-417C-B704-AF55FA6F1924}"/>
           </ac:spMkLst>
         </pc:spChg>
+        <pc:spChg chg="mod">
+          <ac:chgData name="Tobias Unger" userId="0a5458e38b5f4a0f" providerId="LiveId" clId="{5C6CAE59-BAC7-4E9C-B1A6-AA8C1CFC41BD}" dt="2026-09-30T14:09:31.988" v="1195" actId="27636"/>
+          <ac:spMkLst>
+            <pc:docMk/>
+            <pc:sldMk cId="936990828" sldId="257"/>
+            <ac:spMk id="10" creationId="{B459B8CD-9C7A-4679-9427-04FAE8980F04}"/>
+          </ac:spMkLst>
+        </pc:spChg>
         <pc:spChg chg="del mod">
           <ac:chgData name="Tobias Unger" userId="0a5458e38b5f4a0f" providerId="LiveId" clId="{5C6CAE59-BAC7-4E9C-B1A6-AA8C1CFC41BD}" dt="2026-09-30T13:03:17.623" v="1" actId="478"/>
           <ac:spMkLst>
@@ -230,7 +611,7 @@
           </ac:spMkLst>
         </pc:spChg>
         <pc:spChg chg="mod">
-          <ac:chgData name="Tobias Unger" userId="0a5458e38b5f4a0f" providerId="LiveId" clId="{5C6CAE59-BAC7-4E9C-B1A6-AA8C1CFC41BD}" dt="2026-09-30T13:05:31.129" v="329" actId="255"/>
+          <ac:chgData name="Tobias Unger" userId="0a5458e38b5f4a0f" providerId="LiveId" clId="{5C6CAE59-BAC7-4E9C-B1A6-AA8C1CFC41BD}" dt="2026-09-30T13:18:36.189" v="373" actId="255"/>
           <ac:spMkLst>
             <pc:docMk/>
             <pc:sldMk cId="936990828" sldId="257"/>
@@ -245,8 +626,24 @@
             <ac:spMk id="29" creationId="{AEF258EC-5E44-41BA-9936-B4ACFCC590F7}"/>
           </ac:spMkLst>
         </pc:spChg>
+        <pc:spChg chg="mod">
+          <ac:chgData name="Tobias Unger" userId="0a5458e38b5f4a0f" providerId="LiveId" clId="{5C6CAE59-BAC7-4E9C-B1A6-AA8C1CFC41BD}" dt="2026-09-30T14:36:30.613" v="1347" actId="1035"/>
+          <ac:spMkLst>
+            <pc:docMk/>
+            <pc:sldMk cId="936990828" sldId="257"/>
+            <ac:spMk id="30" creationId="{AD6285BD-05BD-4066-9D26-23158FC70C2A}"/>
+          </ac:spMkLst>
+        </pc:spChg>
+        <pc:spChg chg="mod">
+          <ac:chgData name="Tobias Unger" userId="0a5458e38b5f4a0f" providerId="LiveId" clId="{5C6CAE59-BAC7-4E9C-B1A6-AA8C1CFC41BD}" dt="2026-09-30T14:00:48.836" v="1019" actId="27636"/>
+          <ac:spMkLst>
+            <pc:docMk/>
+            <pc:sldMk cId="936990828" sldId="257"/>
+            <ac:spMk id="31" creationId="{8596D9F5-1F43-4459-B0E2-AD8BC5A93947}"/>
+          </ac:spMkLst>
+        </pc:spChg>
         <pc:spChg chg="add mod">
-          <ac:chgData name="Tobias Unger" userId="0a5458e38b5f4a0f" providerId="LiveId" clId="{5C6CAE59-BAC7-4E9C-B1A6-AA8C1CFC41BD}" dt="2026-09-30T13:05:47.244" v="340" actId="1076"/>
+          <ac:chgData name="Tobias Unger" userId="0a5458e38b5f4a0f" providerId="LiveId" clId="{5C6CAE59-BAC7-4E9C-B1A6-AA8C1CFC41BD}" dt="2026-09-30T13:18:42.210" v="374" actId="255"/>
           <ac:spMkLst>
             <pc:docMk/>
             <pc:sldMk cId="936990828" sldId="257"/>
@@ -971,7 +1368,7 @@
         </p:spPr>
         <p:txBody>
           <a:bodyPr>
-            <a:normAutofit fontScale="94792"/>
+            <a:normAutofit fontScale="94792" lnSpcReduction="10000"/>
           </a:bodyPr>
           <a:lstStyle/>
           <a:p>
@@ -1028,7 +1425,7 @@
         </p:spPr>
         <p:txBody>
           <a:bodyPr>
-            <a:normAutofit fontScale="90196"/>
+            <a:normAutofit fontScale="97696" lnSpcReduction="10000"/>
           </a:bodyPr>
           <a:lstStyle/>
           <a:p>
@@ -1043,15 +1440,92 @@
               </a:defRPr>
             </a:pPr>
             <a:r>
-              <a:rPr sz="1275" b="0">
-                <a:solidFill>
-                  <a:srgbClr val="4B5563"/>
-                </a:solidFill>
-                <a:latin typeface="Arial"/>
-                <a:ea typeface="Arial"/>
-                <a:cs typeface="Arial"/>
-              </a:rPr>
-              <a:t>Globale Koordinaten im Bezugssystem world</a:t>
+              <a:rPr sz="1275" b="0" dirty="0" err="1">
+                <a:solidFill>
+                  <a:srgbClr val="4B5563"/>
+                </a:solidFill>
+                <a:latin typeface="Arial"/>
+                <a:ea typeface="Arial"/>
+                <a:cs typeface="Arial"/>
+              </a:rPr>
+              <a:t>Globale</a:t>
+            </a:r>
+            <a:r>
+              <a:rPr sz="1275" b="0" dirty="0">
+                <a:solidFill>
+                  <a:srgbClr val="4B5563"/>
+                </a:solidFill>
+                <a:latin typeface="Arial"/>
+                <a:ea typeface="Arial"/>
+                <a:cs typeface="Arial"/>
+              </a:rPr>
+              <a:t> </a:t>
+            </a:r>
+            <a:r>
+              <a:rPr sz="1275" b="0" dirty="0" err="1">
+                <a:solidFill>
+                  <a:srgbClr val="4B5563"/>
+                </a:solidFill>
+                <a:latin typeface="Arial"/>
+                <a:ea typeface="Arial"/>
+                <a:cs typeface="Arial"/>
+              </a:rPr>
+              <a:t>Koordinaten</a:t>
+            </a:r>
+            <a:r>
+              <a:rPr sz="1275" b="0" dirty="0">
+                <a:solidFill>
+                  <a:srgbClr val="4B5563"/>
+                </a:solidFill>
+                <a:latin typeface="Arial"/>
+                <a:ea typeface="Arial"/>
+                <a:cs typeface="Arial"/>
+              </a:rPr>
+              <a:t> </a:t>
+            </a:r>
+            <a:r>
+              <a:rPr sz="1275" b="0" dirty="0" err="1">
+                <a:solidFill>
+                  <a:srgbClr val="4B5563"/>
+                </a:solidFill>
+                <a:latin typeface="Arial"/>
+                <a:ea typeface="Arial"/>
+                <a:cs typeface="Arial"/>
+              </a:rPr>
+              <a:t>im</a:t>
+            </a:r>
+            <a:r>
+              <a:rPr sz="1275" b="0" dirty="0">
+                <a:solidFill>
+                  <a:srgbClr val="4B5563"/>
+                </a:solidFill>
+                <a:latin typeface="Arial"/>
+                <a:ea typeface="Arial"/>
+                <a:cs typeface="Arial"/>
+              </a:rPr>
+              <a:t> </a:t>
+            </a:r>
+            <a:r>
+              <a:rPr sz="1275" b="0" dirty="0" err="1">
+                <a:solidFill>
+                  <a:srgbClr val="4B5563"/>
+                </a:solidFill>
+                <a:latin typeface="Arial"/>
+                <a:ea typeface="Arial"/>
+                <a:cs typeface="Arial"/>
+              </a:rPr>
+              <a:t>Bezugssystem</a:t>
+            </a:r>
+            <a:r>
+              <a:rPr sz="1275" b="0" dirty="0">
+                <a:solidFill>
+                  <a:srgbClr val="4B5563"/>
+                </a:solidFill>
+                <a:latin typeface="Arial"/>
+                <a:ea typeface="Arial"/>
+                <a:cs typeface="Arial"/>
+              </a:rPr>
+              <a:t> world</a:t>
             </a:r>
           </a:p>
         </p:txBody>
@@ -1072,7 +1546,7 @@
         </p:nvSpPr>
         <p:spPr>
           <a:xfrm>
-            <a:off x="1524000" y="1428750"/>
+            <a:off x="1524000" y="1810257"/>
             <a:ext cx="4000500" cy="4000500"/>
           </a:xfrm>
           <a:prstGeom prst="roundRect">
@@ -1090,6 +1564,13 @@
             <a:prstDash val="solid"/>
           </a:ln>
         </p:spPr>
+        <p:txBody>
+          <a:bodyPr/>
+          <a:lstStyle/>
+          <a:p>
+            <a:endParaRPr lang="de-DE"/>
+          </a:p>
+        </p:txBody>
       </p:sp>
       <p:sp>
         <p:nvSpPr>
@@ -1107,7 +1588,7 @@
         </p:nvSpPr>
         <p:spPr>
           <a:xfrm>
-            <a:off x="2762250" y="1619250"/>
+            <a:off x="1939902" y="2098949"/>
             <a:ext cx="1428750" cy="285750"/>
           </a:xfrm>
           <a:prstGeom prst="rect">
@@ -1120,11 +1601,11 @@
         </p:spPr>
         <p:txBody>
           <a:bodyPr>
-            <a:normAutofit fontScale="80952"/>
+            <a:normAutofit fontScale="88452" lnSpcReduction="10000"/>
           </a:bodyPr>
           <a:lstStyle/>
           <a:p>
-            <a:pPr algn="ctr">
+            <a:pPr>
               <a:defRPr sz="1575" b="1">
                 <a:solidFill>
                   <a:srgbClr val="17212B"/>
@@ -1135,7 +1616,7 @@
               </a:defRPr>
             </a:pPr>
             <a:r>
-              <a:rPr sz="1575" b="1">
+              <a:rPr sz="1575" b="1" dirty="0" err="1">
                 <a:solidFill>
                   <a:srgbClr val="17212B"/>
                 </a:solidFill>
@@ -1145,6 +1626,14 @@
               </a:rPr>
               <a:t>Förderband</a:t>
             </a:r>
+            <a:endParaRPr sz="1575" b="1" dirty="0">
+              <a:solidFill>
+                <a:srgbClr val="17212B"/>
+              </a:solidFill>
+              <a:latin typeface="Arial"/>
+              <a:ea typeface="Arial"/>
+              <a:cs typeface="Arial"/>
+            </a:endParaRPr>
           </a:p>
         </p:txBody>
       </p:sp>
@@ -1164,7 +1653,7 @@
         </p:nvSpPr>
         <p:spPr>
           <a:xfrm>
-            <a:off x="1905000" y="3314700"/>
+            <a:off x="1905000" y="3696207"/>
             <a:ext cx="3371850" cy="1990725"/>
           </a:xfrm>
           <a:prstGeom prst="rect">
@@ -1195,7 +1684,7 @@
         </p:nvSpPr>
         <p:spPr>
           <a:xfrm>
-            <a:off x="3524250" y="2381250"/>
+            <a:off x="3524250" y="2762757"/>
             <a:ext cx="9525" cy="2238375"/>
           </a:xfrm>
           <a:prstGeom prst="line">
@@ -1209,6 +1698,13 @@
             <a:prstDash val="solid"/>
           </a:ln>
         </p:spPr>
+        <p:txBody>
+          <a:bodyPr/>
+          <a:lstStyle/>
+          <a:p>
+            <a:endParaRPr lang="de-DE"/>
+          </a:p>
+        </p:txBody>
       </p:sp>
       <p:sp>
         <p:nvSpPr>
@@ -1226,7 +1722,7 @@
         </p:nvSpPr>
         <p:spPr>
           <a:xfrm rot="10800000">
-            <a:off x="3409950" y="4572000"/>
+            <a:off x="3409950" y="4953507"/>
             <a:ext cx="228600" cy="247650"/>
           </a:xfrm>
           <a:prstGeom prst="triangle">
@@ -1258,7 +1754,7 @@
         </p:nvSpPr>
         <p:spPr>
           <a:xfrm>
-            <a:off x="3143250" y="1162050"/>
+            <a:off x="3143250" y="1543557"/>
             <a:ext cx="762000" cy="209550"/>
           </a:xfrm>
           <a:prstGeom prst="roundRect">
@@ -1276,37 +1772,13 @@
             <a:prstDash val="solid"/>
           </a:ln>
         </p:spPr>
-      </p:sp>
-      <p:sp>
-        <p:nvSpPr>
-          <p:cNvPr id="9" name="Gerader Verbinder 8">
-            <a:extLst>
-              <a:ext uri="{FF2B5EF4-FFF2-40B4-BE49-F238E27FC236}">
-                <a16:creationId xmlns:a16="http://schemas.microsoft.com/office/drawing/2014/main" id="{A4B5AB90-A8BF-4E36-AC6F-1FA54F2E7A11}"/>
-              </a:ext>
-            </a:extLst>
-          </p:cNvPr>
-          <p:cNvSpPr>
-            <a:spLocks noGrp="1"/>
-          </p:cNvSpPr>
-          <p:nvPr/>
-        </p:nvSpPr>
-        <p:spPr>
-          <a:xfrm>
-            <a:off x="3524250" y="1371600"/>
-            <a:ext cx="9525" cy="57150"/>
-          </a:xfrm>
-          <a:prstGeom prst="line">
-            <a:avLst/>
-          </a:prstGeom>
-          <a:noFill/>
-          <a:ln w="19050">
-            <a:solidFill>
-              <a:srgbClr val="4B5563"/>
-            </a:solidFill>
-            <a:prstDash val="solid"/>
-          </a:ln>
-        </p:spPr>
+        <p:txBody>
+          <a:bodyPr/>
+          <a:lstStyle/>
+          <a:p>
+            <a:endParaRPr lang="de-DE" dirty="0"/>
+          </a:p>
+        </p:txBody>
       </p:sp>
       <p:sp>
         <p:nvSpPr>
@@ -1324,7 +1796,7 @@
         </p:nvSpPr>
         <p:spPr>
           <a:xfrm>
-            <a:off x="609600" y="1314450"/>
+            <a:off x="3890101" y="1251045"/>
             <a:ext cx="1619250" cy="266700"/>
           </a:xfrm>
           <a:prstGeom prst="rect">
@@ -1337,7 +1809,7 @@
         </p:spPr>
         <p:txBody>
           <a:bodyPr>
-            <a:normAutofit fontScale="76667"/>
+            <a:normAutofit fontScale="84167" lnSpcReduction="20000"/>
           </a:bodyPr>
           <a:lstStyle/>
           <a:p>
@@ -1352,7 +1824,7 @@
               </a:defRPr>
             </a:pPr>
             <a:r>
-              <a:rPr sz="1500" b="1">
+              <a:rPr sz="1500" b="1" dirty="0">
                 <a:solidFill>
                   <a:srgbClr val="17212B"/>
                 </a:solidFill>
@@ -1381,7 +1853,7 @@
         </p:nvSpPr>
         <p:spPr>
           <a:xfrm>
-            <a:off x="609600" y="1619250"/>
+            <a:off x="3895770" y="1419537"/>
             <a:ext cx="2000250" cy="457200"/>
           </a:xfrm>
           <a:prstGeom prst="rect">
@@ -1409,16 +1881,46 @@
               </a:defRPr>
             </a:pPr>
             <a:r>
-              <a:rPr sz="1200" b="0">
-                <a:solidFill>
-                  <a:srgbClr val="4B5563"/>
-                </a:solidFill>
-                <a:latin typeface="Arial"/>
-                <a:ea typeface="Arial"/>
-                <a:cs typeface="Arial"/>
-              </a:rPr>
-              <a:t>mittig am Bandanfang</a:t>
-            </a:r>
+              <a:rPr sz="900" b="0" dirty="0" err="1">
+                <a:solidFill>
+                  <a:srgbClr val="4B5563"/>
+                </a:solidFill>
+                <a:latin typeface="Arial"/>
+                <a:ea typeface="Arial"/>
+                <a:cs typeface="Arial"/>
+              </a:rPr>
+              <a:t>mittig</a:t>
+            </a:r>
+            <a:r>
+              <a:rPr sz="900" b="0" dirty="0">
+                <a:solidFill>
+                  <a:srgbClr val="4B5563"/>
+                </a:solidFill>
+                <a:latin typeface="Arial"/>
+                <a:ea typeface="Arial"/>
+                <a:cs typeface="Arial"/>
+              </a:rPr>
+              <a:t> am </a:t>
+            </a:r>
+            <a:r>
+              <a:rPr sz="900" b="0" dirty="0" err="1">
+                <a:solidFill>
+                  <a:srgbClr val="4B5563"/>
+                </a:solidFill>
+                <a:latin typeface="Arial"/>
+                <a:ea typeface="Arial"/>
+                <a:cs typeface="Arial"/>
+              </a:rPr>
+              <a:t>Bandanfang</a:t>
+            </a:r>
+            <a:endParaRPr sz="900" b="0" dirty="0">
+              <a:solidFill>
+                <a:srgbClr val="4B5563"/>
+              </a:solidFill>
+              <a:latin typeface="Arial"/>
+              <a:ea typeface="Arial"/>
+              <a:cs typeface="Arial"/>
+            </a:endParaRPr>
           </a:p>
           <a:p>
             <a:pPr algn="l">
@@ -1432,15 +1934,37 @@
               </a:defRPr>
             </a:pPr>
             <a:r>
-              <a:rPr sz="1200" b="0">
-                <a:solidFill>
-                  <a:srgbClr val="4B5563"/>
-                </a:solidFill>
-                <a:latin typeface="Arial"/>
-                <a:ea typeface="Arial"/>
-                <a:cs typeface="Arial"/>
-              </a:rPr>
-              <a:t>ca. 0,850 m über Band</a:t>
+              <a:rPr sz="900" b="0" dirty="0">
+                <a:solidFill>
+                  <a:srgbClr val="4B5563"/>
+                </a:solidFill>
+                <a:latin typeface="Arial"/>
+                <a:ea typeface="Arial"/>
+                <a:cs typeface="Arial"/>
+              </a:rPr>
+              <a:t>ca. 0,850 m </a:t>
+            </a:r>
+            <a:r>
+              <a:rPr sz="900" b="0" dirty="0" err="1">
+                <a:solidFill>
+                  <a:srgbClr val="4B5563"/>
+                </a:solidFill>
+                <a:latin typeface="Arial"/>
+                <a:ea typeface="Arial"/>
+                <a:cs typeface="Arial"/>
+              </a:rPr>
+              <a:t>über</a:t>
+            </a:r>
+            <a:r>
+              <a:rPr sz="900" b="0" dirty="0">
+                <a:solidFill>
+                  <a:srgbClr val="4B5563"/>
+                </a:solidFill>
+                <a:latin typeface="Arial"/>
+                <a:ea typeface="Arial"/>
+                <a:cs typeface="Arial"/>
+              </a:rPr>
+              <a:t> Band</a:t>
             </a:r>
           </a:p>
         </p:txBody>
@@ -1461,7 +1985,7 @@
         </p:nvSpPr>
         <p:spPr>
           <a:xfrm>
-            <a:off x="2857500" y="1428750"/>
+            <a:off x="2857500" y="1810257"/>
             <a:ext cx="666750" cy="9525"/>
           </a:xfrm>
           <a:prstGeom prst="line">
@@ -1492,7 +2016,7 @@
         </p:nvSpPr>
         <p:spPr>
           <a:xfrm rot="16200000">
-            <a:off x="2724150" y="1362075"/>
+            <a:off x="2724150" y="1743582"/>
             <a:ext cx="152400" cy="133350"/>
           </a:xfrm>
           <a:prstGeom prst="triangle">
@@ -1524,7 +2048,7 @@
         </p:nvSpPr>
         <p:spPr>
           <a:xfrm>
-            <a:off x="3524250" y="1428750"/>
+            <a:off x="3524250" y="1810257"/>
             <a:ext cx="9525" cy="666750"/>
           </a:xfrm>
           <a:prstGeom prst="line">
@@ -1538,6 +2062,13 @@
             <a:prstDash val="solid"/>
           </a:ln>
         </p:spPr>
+        <p:txBody>
+          <a:bodyPr/>
+          <a:lstStyle/>
+          <a:p>
+            <a:endParaRPr lang="de-DE"/>
+          </a:p>
+        </p:txBody>
       </p:sp>
       <p:sp>
         <p:nvSpPr>
@@ -1555,7 +2086,7 @@
         </p:nvSpPr>
         <p:spPr>
           <a:xfrm rot="10800000">
-            <a:off x="3457575" y="1971675"/>
+            <a:off x="3457575" y="2353182"/>
             <a:ext cx="133350" cy="152400"/>
           </a:xfrm>
           <a:prstGeom prst="triangle">
@@ -1587,8 +2118,8 @@
         </p:nvSpPr>
         <p:spPr>
           <a:xfrm>
-            <a:off x="2714625" y="1181100"/>
-            <a:ext cx="333375" cy="171450"/>
+            <a:off x="2328392" y="1483882"/>
+            <a:ext cx="761999" cy="285749"/>
           </a:xfrm>
           <a:prstGeom prst="rect">
             <a:avLst/>
@@ -1600,7 +2131,7 @@
         </p:spPr>
         <p:txBody>
           <a:bodyPr>
-            <a:normAutofit fontScale="50000"/>
+            <a:noAutofit/>
           </a:bodyPr>
           <a:lstStyle/>
           <a:p>
@@ -1615,7 +2146,7 @@
               </a:defRPr>
             </a:pPr>
             <a:r>
-              <a:rPr sz="1050" b="0">
+              <a:rPr sz="1900" b="0" dirty="0">
                 <a:solidFill>
                   <a:srgbClr val="1D70B8"/>
                 </a:solidFill>
@@ -1644,8 +2175,8 @@
         </p:nvSpPr>
         <p:spPr>
           <a:xfrm>
-            <a:off x="3667125" y="1981200"/>
-            <a:ext cx="333375" cy="171450"/>
+            <a:off x="3624734" y="2265815"/>
+            <a:ext cx="632372" cy="345663"/>
           </a:xfrm>
           <a:prstGeom prst="rect">
             <a:avLst/>
@@ -1657,7 +2188,7 @@
         </p:spPr>
         <p:txBody>
           <a:bodyPr>
-            <a:normAutofit fontScale="50000"/>
+            <a:noAutofit/>
           </a:bodyPr>
           <a:lstStyle/>
           <a:p>
@@ -1672,7 +2203,7 @@
               </a:defRPr>
             </a:pPr>
             <a:r>
-              <a:rPr sz="1050" b="0">
+              <a:rPr sz="1900" b="0" dirty="0">
                 <a:solidFill>
                   <a:srgbClr val="1D70B8"/>
                 </a:solidFill>
@@ -1701,7 +2232,7 @@
         </p:nvSpPr>
         <p:spPr>
           <a:xfrm>
-            <a:off x="2047875" y="2143125"/>
+            <a:off x="3524249" y="2024374"/>
             <a:ext cx="1476375" cy="190500"/>
           </a:xfrm>
           <a:prstGeom prst="rect">
@@ -1714,7 +2245,7 @@
         </p:spPr>
         <p:txBody>
           <a:bodyPr>
-            <a:normAutofit fontScale="61905"/>
+            <a:noAutofit/>
           </a:bodyPr>
           <a:lstStyle/>
           <a:p>
@@ -1729,7 +2260,7 @@
               </a:defRPr>
             </a:pPr>
             <a:r>
-              <a:rPr sz="1050" b="0">
+              <a:rPr sz="1300" b="0" dirty="0" err="1">
                 <a:solidFill>
                   <a:srgbClr val="1D70B8"/>
                 </a:solidFill>
@@ -1739,6 +2270,14 @@
               </a:rPr>
               <a:t>conveyor_frame</a:t>
             </a:r>
+            <a:endParaRPr sz="1300" b="0" dirty="0">
+              <a:solidFill>
+                <a:srgbClr val="1D70B8"/>
+              </a:solidFill>
+              <a:latin typeface="Arial"/>
+              <a:ea typeface="Arial"/>
+              <a:cs typeface="Arial"/>
+            </a:endParaRPr>
           </a:p>
         </p:txBody>
       </p:sp>
@@ -1793,8 +2332,8 @@
         </p:nvSpPr>
         <p:spPr>
           <a:xfrm>
-            <a:off x="6076950" y="2943225"/>
-            <a:ext cx="914400" cy="219075"/>
+            <a:off x="6021717" y="2728171"/>
+            <a:ext cx="1066800" cy="400050"/>
           </a:xfrm>
           <a:prstGeom prst="rect">
             <a:avLst/>
@@ -1806,7 +2345,7 @@
         </p:spPr>
         <p:txBody>
           <a:bodyPr>
-            <a:normAutofit fontScale="69792"/>
+            <a:noAutofit/>
           </a:bodyPr>
           <a:lstStyle/>
           <a:p>
@@ -1821,7 +2360,7 @@
               </a:defRPr>
             </a:pPr>
             <a:r>
-              <a:rPr sz="1200" b="0">
+              <a:rPr sz="1900" b="0" dirty="0" err="1">
                 <a:solidFill>
                   <a:srgbClr val="17212B"/>
                 </a:solidFill>
@@ -1829,8 +2368,38 @@
                 <a:ea typeface="Arial"/>
                 <a:cs typeface="Arial"/>
               </a:rPr>
-              <a:t>Ablagekiste</a:t>
-            </a:r>
+              <a:t>Ablage</a:t>
+            </a:r>
+            <a:r>
+              <a:rPr lang="de-DE" sz="1900" b="0" dirty="0">
+                <a:solidFill>
+                  <a:srgbClr val="17212B"/>
+                </a:solidFill>
+                <a:latin typeface="Arial"/>
+                <a:ea typeface="Arial"/>
+                <a:cs typeface="Arial"/>
+              </a:rPr>
+              <a:t>- </a:t>
+            </a:r>
+            <a:r>
+              <a:rPr sz="1900" b="0" dirty="0" err="1">
+                <a:solidFill>
+                  <a:srgbClr val="17212B"/>
+                </a:solidFill>
+                <a:latin typeface="Arial"/>
+                <a:ea typeface="Arial"/>
+                <a:cs typeface="Arial"/>
+              </a:rPr>
+              <a:t>kiste</a:t>
+            </a:r>
+            <a:endParaRPr sz="1900" b="0" dirty="0">
+              <a:solidFill>
+                <a:srgbClr val="17212B"/>
+              </a:solidFill>
+              <a:latin typeface="Arial"/>
+              <a:ea typeface="Arial"/>
+              <a:cs typeface="Arial"/>
+            </a:endParaRPr>
           </a:p>
         </p:txBody>
       </p:sp>
@@ -1850,7 +2419,7 @@
         </p:nvSpPr>
         <p:spPr>
           <a:xfrm>
-            <a:off x="7562850" y="4095750"/>
+            <a:off x="6038850" y="4086225"/>
             <a:ext cx="1066800" cy="1066800"/>
           </a:xfrm>
           <a:prstGeom prst="ellipse">
@@ -1866,6 +2435,13 @@
             <a:prstDash val="solid"/>
           </a:ln>
         </p:spPr>
+        <p:txBody>
+          <a:bodyPr/>
+          <a:lstStyle/>
+          <a:p>
+            <a:endParaRPr lang="de-DE"/>
+          </a:p>
+        </p:txBody>
       </p:sp>
       <p:sp>
         <p:nvSpPr>
@@ -1883,8 +2459,8 @@
         </p:nvSpPr>
         <p:spPr>
           <a:xfrm>
-            <a:off x="7734300" y="4857750"/>
-            <a:ext cx="723900" cy="209550"/>
+            <a:off x="5992350" y="4640937"/>
+            <a:ext cx="1143000" cy="395578"/>
           </a:xfrm>
           <a:prstGeom prst="rect">
             <a:avLst/>
@@ -1896,7 +2472,7 @@
         </p:spPr>
         <p:txBody>
           <a:bodyPr>
-            <a:normAutofit fontScale="60784"/>
+            <a:noAutofit/>
           </a:bodyPr>
           <a:lstStyle/>
           <a:p>
@@ -1911,7 +2487,7 @@
               </a:defRPr>
             </a:pPr>
             <a:r>
-              <a:rPr sz="1275" b="0">
+              <a:rPr sz="1900" b="0" dirty="0">
                 <a:solidFill>
                   <a:srgbClr val="17212B"/>
                 </a:solidFill>
@@ -1940,7 +2516,7 @@
         </p:nvSpPr>
         <p:spPr>
           <a:xfrm>
-            <a:off x="8096250" y="4629150"/>
+            <a:off x="6572250" y="4619625"/>
             <a:ext cx="742950" cy="9525"/>
           </a:xfrm>
           <a:prstGeom prst="line">
@@ -1971,7 +2547,7 @@
         </p:nvSpPr>
         <p:spPr>
           <a:xfrm rot="5400000">
-            <a:off x="8801100" y="4562475"/>
+            <a:off x="7277100" y="4552950"/>
             <a:ext cx="133350" cy="133350"/>
           </a:xfrm>
           <a:prstGeom prst="triangle">
@@ -2003,7 +2579,7 @@
         </p:nvSpPr>
         <p:spPr>
           <a:xfrm>
-            <a:off x="8096250" y="3981450"/>
+            <a:off x="6572250" y="3971925"/>
             <a:ext cx="9525" cy="647700"/>
           </a:xfrm>
           <a:prstGeom prst="line">
@@ -2034,7 +2610,7 @@
         </p:nvSpPr>
         <p:spPr>
           <a:xfrm>
-            <a:off x="8029575" y="3943350"/>
+            <a:off x="6505575" y="3933825"/>
             <a:ext cx="133350" cy="133350"/>
           </a:xfrm>
           <a:prstGeom prst="triangle">
@@ -2066,8 +2642,8 @@
         </p:nvSpPr>
         <p:spPr>
           <a:xfrm>
-            <a:off x="8743950" y="4362450"/>
-            <a:ext cx="333375" cy="171450"/>
+            <a:off x="7219950" y="4224048"/>
+            <a:ext cx="628650" cy="304800"/>
           </a:xfrm>
           <a:prstGeom prst="rect">
             <a:avLst/>
@@ -2079,7 +2655,7 @@
         </p:spPr>
         <p:txBody>
           <a:bodyPr>
-            <a:normAutofit fontScale="50000"/>
+            <a:noAutofit/>
           </a:bodyPr>
           <a:lstStyle/>
           <a:p>
@@ -2094,7 +2670,7 @@
               </a:defRPr>
             </a:pPr>
             <a:r>
-              <a:rPr sz="1050" b="0">
+              <a:rPr sz="1900" b="0" dirty="0">
                 <a:solidFill>
                   <a:srgbClr val="1D70B8"/>
                 </a:solidFill>
@@ -2123,7 +2699,7 @@
         </p:nvSpPr>
         <p:spPr>
           <a:xfrm>
-            <a:off x="8239125" y="3295651"/>
+            <a:off x="6463508" y="3586838"/>
             <a:ext cx="752475" cy="685799"/>
           </a:xfrm>
           <a:prstGeom prst="rect">
@@ -2180,8 +2756,8 @@
         </p:nvSpPr>
         <p:spPr>
           <a:xfrm>
-            <a:off x="8953500" y="4762500"/>
-            <a:ext cx="666750" cy="171450"/>
+            <a:off x="7241773" y="4752975"/>
+            <a:ext cx="1333500" cy="476250"/>
           </a:xfrm>
           <a:prstGeom prst="rect">
             <a:avLst/>
@@ -2193,7 +2769,7 @@
         </p:spPr>
         <p:txBody>
           <a:bodyPr>
-            <a:normAutofit fontScale="50000"/>
+            <a:noAutofit/>
           </a:bodyPr>
           <a:lstStyle/>
           <a:p>
@@ -2208,7 +2784,7 @@
               </a:defRPr>
             </a:pPr>
             <a:r>
-              <a:rPr sz="1050" b="0">
+              <a:rPr sz="1300" b="0" dirty="0">
                 <a:solidFill>
                   <a:srgbClr val="1D70B8"/>
                 </a:solidFill>
@@ -2250,7 +2826,7 @@
         </p:spPr>
         <p:txBody>
           <a:bodyPr>
-            <a:normAutofit fontScale="80952"/>
+            <a:normAutofit fontScale="88452" lnSpcReduction="10000"/>
           </a:bodyPr>
           <a:lstStyle/>
           <a:p>
@@ -2265,7 +2841,7 @@
               </a:defRPr>
             </a:pPr>
             <a:r>
-              <a:rPr sz="1575" b="1">
+              <a:rPr sz="1575" b="1" dirty="0" err="1">
                 <a:solidFill>
                   <a:srgbClr val="1D70B8"/>
                 </a:solidFill>
@@ -2273,8 +2849,38 @@
                 <a:ea typeface="Arial"/>
                 <a:cs typeface="Arial"/>
               </a:rPr>
-              <a:t>Greifbarer Arbeitsbereich</a:t>
-            </a:r>
+              <a:t>Greifbarer</a:t>
+            </a:r>
+            <a:r>
+              <a:rPr sz="1575" b="1" dirty="0">
+                <a:solidFill>
+                  <a:srgbClr val="1D70B8"/>
+                </a:solidFill>
+                <a:latin typeface="Arial"/>
+                <a:ea typeface="Arial"/>
+                <a:cs typeface="Arial"/>
+              </a:rPr>
+              <a:t> </a:t>
+            </a:r>
+            <a:r>
+              <a:rPr sz="1575" b="1" dirty="0" err="1">
+                <a:solidFill>
+                  <a:srgbClr val="1D70B8"/>
+                </a:solidFill>
+                <a:latin typeface="Arial"/>
+                <a:ea typeface="Arial"/>
+                <a:cs typeface="Arial"/>
+              </a:rPr>
+              <a:t>Arbeitsbereich</a:t>
+            </a:r>
+            <a:endParaRPr sz="1575" b="1" dirty="0">
+              <a:solidFill>
+                <a:srgbClr val="1D70B8"/>
+              </a:solidFill>
+              <a:latin typeface="Arial"/>
+              <a:ea typeface="Arial"/>
+              <a:cs typeface="Arial"/>
+            </a:endParaRPr>
           </a:p>
         </p:txBody>
       </p:sp>
@@ -2322,7 +2928,7 @@
               </a:defRPr>
             </a:pPr>
             <a:r>
-              <a:rPr sz="1350" b="0">
+              <a:rPr sz="1350" b="0" dirty="0">
                 <a:solidFill>
                   <a:srgbClr val="1D70B8"/>
                 </a:solidFill>
@@ -2345,7 +2951,7 @@
               </a:defRPr>
             </a:pPr>
             <a:r>
-              <a:rPr sz="1350" b="0">
+              <a:rPr sz="1350" b="0" dirty="0">
                 <a:solidFill>
                   <a:srgbClr val="1D70B8"/>
                 </a:solidFill>
@@ -2387,7 +2993,7 @@
         </p:spPr>
         <p:txBody>
           <a:bodyPr>
-            <a:normAutofit fontScale="73016"/>
+            <a:normAutofit fontScale="80516" lnSpcReduction="20000"/>
           </a:bodyPr>
           <a:lstStyle/>
           <a:p>
@@ -2444,7 +3050,7 @@
         </p:spPr>
         <p:txBody>
           <a:bodyPr>
-            <a:normAutofit fontScale="93210"/>
+            <a:normAutofit fontScale="93210" lnSpcReduction="10000"/>
           </a:bodyPr>
           <a:lstStyle/>
           <a:p>
@@ -2459,7 +3065,7 @@
               </a:defRPr>
             </a:pPr>
             <a:r>
-              <a:rPr sz="1350" b="0">
+              <a:rPr sz="1350" b="0" dirty="0">
                 <a:solidFill>
                   <a:srgbClr val="17212B"/>
                 </a:solidFill>
@@ -2482,7 +3088,7 @@
               </a:defRPr>
             </a:pPr>
             <a:r>
-              <a:rPr sz="1350" b="0">
+              <a:rPr sz="1350" b="0" dirty="0">
                 <a:solidFill>
                   <a:srgbClr val="17212B"/>
                 </a:solidFill>
@@ -2505,7 +3111,7 @@
               </a:defRPr>
             </a:pPr>
             <a:r>
-              <a:rPr sz="1350" b="0">
+              <a:rPr sz="1350" b="0" dirty="0">
                 <a:solidFill>
                   <a:srgbClr val="17212B"/>
                 </a:solidFill>
@@ -2534,8 +3140,8 @@
         </p:nvSpPr>
         <p:spPr>
           <a:xfrm>
-            <a:off x="1524000" y="5810250"/>
-            <a:ext cx="3714750" cy="228600"/>
+            <a:off x="1524000" y="6029305"/>
+            <a:ext cx="3996000" cy="502078"/>
           </a:xfrm>
           <a:prstGeom prst="rect">
             <a:avLst/>
@@ -2547,11 +3153,11 @@
         </p:spPr>
         <p:txBody>
           <a:bodyPr>
-            <a:normAutofit fontScale="70588"/>
+            <a:normAutofit fontScale="93088"/>
           </a:bodyPr>
           <a:lstStyle/>
           <a:p>
-            <a:pPr algn="l">
+            <a:pPr algn="ctr">
               <a:defRPr sz="1275" b="0">
                 <a:solidFill>
                   <a:srgbClr val="4B5563"/>
@@ -2562,15 +3168,115 @@
               </a:defRPr>
             </a:pPr>
             <a:r>
-              <a:rPr sz="1275" b="0">
-                <a:solidFill>
-                  <a:srgbClr val="4B5563"/>
-                </a:solidFill>
-                <a:latin typeface="Arial"/>
-                <a:ea typeface="Arial"/>
-                <a:cs typeface="Arial"/>
-              </a:rPr>
-              <a:t>Bandkanten: x = -1,275 bis -0,480 m</a:t>
+              <a:rPr lang="de-DE" sz="1275" b="0" dirty="0">
+                <a:solidFill>
+                  <a:srgbClr val="4B5563"/>
+                </a:solidFill>
+                <a:latin typeface="Arial"/>
+                <a:ea typeface="Arial"/>
+                <a:cs typeface="Arial"/>
+              </a:rPr>
+              <a:t>Bandbreite:  0,795 m </a:t>
+            </a:r>
+          </a:p>
+          <a:p>
+            <a:pPr algn="ctr">
+              <a:defRPr sz="1275" b="0">
+                <a:solidFill>
+                  <a:srgbClr val="4B5563"/>
+                </a:solidFill>
+                <a:latin typeface="Arial"/>
+                <a:ea typeface="Arial"/>
+                <a:cs typeface="Arial"/>
+              </a:defRPr>
+            </a:pPr>
+            <a:r>
+              <a:rPr sz="1275" b="0" dirty="0" err="1">
+                <a:solidFill>
+                  <a:srgbClr val="4B5563"/>
+                </a:solidFill>
+                <a:latin typeface="Arial"/>
+                <a:ea typeface="Arial"/>
+                <a:cs typeface="Arial"/>
+              </a:rPr>
+              <a:t>Bandkanten</a:t>
+            </a:r>
+            <a:r>
+              <a:rPr sz="1275" b="0" dirty="0">
+                <a:solidFill>
+                  <a:srgbClr val="4B5563"/>
+                </a:solidFill>
+                <a:latin typeface="Arial"/>
+                <a:ea typeface="Arial"/>
+                <a:cs typeface="Arial"/>
+              </a:rPr>
+              <a:t>: </a:t>
+            </a:r>
+            <a:r>
+              <a:rPr lang="de-DE" sz="1275" b="0" dirty="0">
+                <a:solidFill>
+                  <a:srgbClr val="4B5563"/>
+                </a:solidFill>
+                <a:latin typeface="Arial"/>
+                <a:ea typeface="Arial"/>
+                <a:cs typeface="Arial"/>
+              </a:rPr>
+              <a:t> </a:t>
+            </a:r>
+            <a:r>
+              <a:rPr sz="1275" b="0" dirty="0">
+                <a:solidFill>
+                  <a:srgbClr val="4B5563"/>
+                </a:solidFill>
+                <a:latin typeface="Arial"/>
+                <a:ea typeface="Arial"/>
+                <a:cs typeface="Arial"/>
+              </a:rPr>
+              <a:t>x = -1,275 </a:t>
+            </a:r>
+            <a:r>
+              <a:rPr lang="de-DE" sz="1275" b="0" dirty="0">
+                <a:solidFill>
+                  <a:srgbClr val="4B5563"/>
+                </a:solidFill>
+                <a:latin typeface="Arial"/>
+                <a:ea typeface="Arial"/>
+                <a:cs typeface="Arial"/>
+              </a:rPr>
+              <a:t> </a:t>
+            </a:r>
+            <a:r>
+              <a:rPr sz="1275" b="0" dirty="0">
+                <a:solidFill>
+                  <a:srgbClr val="4B5563"/>
+                </a:solidFill>
+                <a:latin typeface="Arial"/>
+                <a:ea typeface="Arial"/>
+                <a:cs typeface="Arial"/>
+              </a:rPr>
+              <a:t>bis</a:t>
+            </a:r>
+            <a:r>
+              <a:rPr lang="de-DE" sz="1275" b="0" dirty="0">
+                <a:solidFill>
+                  <a:srgbClr val="4B5563"/>
+                </a:solidFill>
+                <a:latin typeface="Arial"/>
+                <a:ea typeface="Arial"/>
+                <a:cs typeface="Arial"/>
+              </a:rPr>
+              <a:t>  x = </a:t>
+            </a:r>
+            <a:r>
+              <a:rPr sz="1275" b="0" dirty="0">
+                <a:solidFill>
+                  <a:srgbClr val="4B5563"/>
+                </a:solidFill>
+                <a:latin typeface="Arial"/>
+                <a:ea typeface="Arial"/>
+                <a:cs typeface="Arial"/>
+              </a:rPr>
+              <a:t>-0,480 m</a:t>
             </a:r>
           </a:p>
         </p:txBody>
@@ -2591,8 +3297,8 @@
         </p:nvSpPr>
         <p:spPr>
           <a:xfrm>
-            <a:off x="1524000" y="6115050"/>
-            <a:ext cx="4095750" cy="228600"/>
+            <a:off x="64466" y="3269664"/>
+            <a:ext cx="1191194" cy="1344725"/>
           </a:xfrm>
           <a:prstGeom prst="rect">
             <a:avLst/>
@@ -2604,11 +3310,11 @@
         </p:spPr>
         <p:txBody>
           <a:bodyPr>
-            <a:normAutofit fontScale="70588"/>
+            <a:normAutofit fontScale="93088"/>
           </a:bodyPr>
           <a:lstStyle/>
           <a:p>
-            <a:pPr algn="l">
+            <a:pPr algn="r">
               <a:defRPr sz="1275" b="0">
                 <a:solidFill>
                   <a:srgbClr val="4B5563"/>
@@ -2619,15 +3325,141 @@
               </a:defRPr>
             </a:pPr>
             <a:r>
-              <a:rPr sz="1275" b="0">
-                <a:solidFill>
-                  <a:srgbClr val="4B5563"/>
-                </a:solidFill>
-                <a:latin typeface="Arial"/>
-                <a:ea typeface="Arial"/>
-                <a:cs typeface="Arial"/>
-              </a:rPr>
-              <a:t>Nutzbare gerade Förderstrecke: ca. 1,507 m</a:t>
+              <a:rPr sz="1275" b="0" dirty="0" err="1">
+                <a:solidFill>
+                  <a:srgbClr val="4B5563"/>
+                </a:solidFill>
+                <a:latin typeface="Arial"/>
+                <a:ea typeface="Arial"/>
+                <a:cs typeface="Arial"/>
+              </a:rPr>
+              <a:t>Nutzbare</a:t>
+            </a:r>
+            <a:r>
+              <a:rPr sz="1275" b="0" dirty="0">
+                <a:solidFill>
+                  <a:srgbClr val="4B5563"/>
+                </a:solidFill>
+                <a:latin typeface="Arial"/>
+                <a:ea typeface="Arial"/>
+                <a:cs typeface="Arial"/>
+              </a:rPr>
+              <a:t> </a:t>
+            </a:r>
+            <a:endParaRPr lang="de-DE" sz="1275" b="0" dirty="0">
+              <a:solidFill>
+                <a:srgbClr val="4B5563"/>
+              </a:solidFill>
+              <a:latin typeface="Arial"/>
+              <a:ea typeface="Arial"/>
+              <a:cs typeface="Arial"/>
+            </a:endParaRPr>
+          </a:p>
+          <a:p>
+            <a:pPr algn="r">
+              <a:defRPr sz="1275" b="0">
+                <a:solidFill>
+                  <a:srgbClr val="4B5563"/>
+                </a:solidFill>
+                <a:latin typeface="Arial"/>
+                <a:ea typeface="Arial"/>
+                <a:cs typeface="Arial"/>
+              </a:defRPr>
+            </a:pPr>
+            <a:r>
+              <a:rPr sz="1275" b="0" dirty="0" err="1">
+                <a:solidFill>
+                  <a:srgbClr val="4B5563"/>
+                </a:solidFill>
+                <a:latin typeface="Arial"/>
+                <a:ea typeface="Arial"/>
+                <a:cs typeface="Arial"/>
+              </a:rPr>
+              <a:t>gerade</a:t>
+            </a:r>
+            <a:r>
+              <a:rPr sz="1275" b="0" dirty="0">
+                <a:solidFill>
+                  <a:srgbClr val="4B5563"/>
+                </a:solidFill>
+                <a:latin typeface="Arial"/>
+                <a:ea typeface="Arial"/>
+                <a:cs typeface="Arial"/>
+              </a:rPr>
+              <a:t> </a:t>
+            </a:r>
+            <a:endParaRPr lang="de-DE" sz="1275" b="0" dirty="0">
+              <a:solidFill>
+                <a:srgbClr val="4B5563"/>
+              </a:solidFill>
+              <a:latin typeface="Arial"/>
+              <a:ea typeface="Arial"/>
+              <a:cs typeface="Arial"/>
+            </a:endParaRPr>
+          </a:p>
+          <a:p>
+            <a:pPr algn="r">
+              <a:defRPr sz="1275" b="0">
+                <a:solidFill>
+                  <a:srgbClr val="4B5563"/>
+                </a:solidFill>
+                <a:latin typeface="Arial"/>
+                <a:ea typeface="Arial"/>
+                <a:cs typeface="Arial"/>
+              </a:defRPr>
+            </a:pPr>
+            <a:r>
+              <a:rPr sz="1275" b="0" dirty="0" err="1">
+                <a:solidFill>
+                  <a:srgbClr val="4B5563"/>
+                </a:solidFill>
+                <a:latin typeface="Arial"/>
+                <a:ea typeface="Arial"/>
+                <a:cs typeface="Arial"/>
+              </a:rPr>
+              <a:t>Förderstrecke</a:t>
+            </a:r>
+            <a:r>
+              <a:rPr sz="1275" b="0" dirty="0">
+                <a:solidFill>
+                  <a:srgbClr val="4B5563"/>
+                </a:solidFill>
+                <a:latin typeface="Arial"/>
+                <a:ea typeface="Arial"/>
+                <a:cs typeface="Arial"/>
+              </a:rPr>
+              <a:t>: </a:t>
+            </a:r>
+            <a:endParaRPr lang="de-DE" sz="1275" b="0" dirty="0">
+              <a:solidFill>
+                <a:srgbClr val="4B5563"/>
+              </a:solidFill>
+              <a:latin typeface="Arial"/>
+              <a:ea typeface="Arial"/>
+              <a:cs typeface="Arial"/>
+            </a:endParaRPr>
+          </a:p>
+          <a:p>
+            <a:pPr algn="r">
+              <a:defRPr sz="1275" b="0">
+                <a:solidFill>
+                  <a:srgbClr val="4B5563"/>
+                </a:solidFill>
+                <a:latin typeface="Arial"/>
+                <a:ea typeface="Arial"/>
+                <a:cs typeface="Arial"/>
+              </a:defRPr>
+            </a:pPr>
+            <a:r>
+              <a:rPr sz="1275" b="0" dirty="0">
+                <a:solidFill>
+                  <a:srgbClr val="4B5563"/>
+                </a:solidFill>
+                <a:latin typeface="Arial"/>
+                <a:ea typeface="Arial"/>
+                <a:cs typeface="Arial"/>
+              </a:rPr>
+              <a:t>ca. 1,507 m</a:t>
             </a:r>
           </a:p>
         </p:txBody>
@@ -2661,7 +3493,7 @@
         </p:spPr>
         <p:txBody>
           <a:bodyPr>
-            <a:normAutofit fontScale="57778"/>
+            <a:normAutofit fontScale="72778" lnSpcReduction="20000"/>
           </a:bodyPr>
           <a:lstStyle/>
           <a:p>
@@ -2676,19 +3508,322 @@
               </a:defRPr>
             </a:pPr>
             <a:r>
-              <a:rPr sz="1125" b="0">
-                <a:solidFill>
-                  <a:srgbClr val="4B5563"/>
-                </a:solidFill>
-                <a:latin typeface="Arial"/>
-                <a:ea typeface="Arial"/>
-                <a:cs typeface="Arial"/>
-              </a:rPr>
-              <a:t>Z+ zeigt von der Bandebene nach oben und ist in der Draufsicht nicht dargestellt.</a:t>
+              <a:rPr sz="1125" b="0" dirty="0">
+                <a:solidFill>
+                  <a:srgbClr val="4B5563"/>
+                </a:solidFill>
+                <a:latin typeface="Arial"/>
+                <a:ea typeface="Arial"/>
+                <a:cs typeface="Arial"/>
+              </a:rPr>
+              <a:t>Z+ </a:t>
+            </a:r>
+            <a:r>
+              <a:rPr sz="1125" b="0" dirty="0" err="1">
+                <a:solidFill>
+                  <a:srgbClr val="4B5563"/>
+                </a:solidFill>
+                <a:latin typeface="Arial"/>
+                <a:ea typeface="Arial"/>
+                <a:cs typeface="Arial"/>
+              </a:rPr>
+              <a:t>zeigt</a:t>
+            </a:r>
+            <a:r>
+              <a:rPr sz="1125" b="0" dirty="0">
+                <a:solidFill>
+                  <a:srgbClr val="4B5563"/>
+                </a:solidFill>
+                <a:latin typeface="Arial"/>
+                <a:ea typeface="Arial"/>
+                <a:cs typeface="Arial"/>
+              </a:rPr>
+              <a:t> von der </a:t>
+            </a:r>
+            <a:r>
+              <a:rPr sz="1125" b="0" dirty="0" err="1">
+                <a:solidFill>
+                  <a:srgbClr val="4B5563"/>
+                </a:solidFill>
+                <a:latin typeface="Arial"/>
+                <a:ea typeface="Arial"/>
+                <a:cs typeface="Arial"/>
+              </a:rPr>
+              <a:t>Bandebene</a:t>
+            </a:r>
+            <a:r>
+              <a:rPr sz="1125" b="0" dirty="0">
+                <a:solidFill>
+                  <a:srgbClr val="4B5563"/>
+                </a:solidFill>
+                <a:latin typeface="Arial"/>
+                <a:ea typeface="Arial"/>
+                <a:cs typeface="Arial"/>
+              </a:rPr>
+              <a:t> </a:t>
+            </a:r>
+            <a:r>
+              <a:rPr sz="1125" b="0" dirty="0" err="1">
+                <a:solidFill>
+                  <a:srgbClr val="4B5563"/>
+                </a:solidFill>
+                <a:latin typeface="Arial"/>
+                <a:ea typeface="Arial"/>
+                <a:cs typeface="Arial"/>
+              </a:rPr>
+              <a:t>nach</a:t>
+            </a:r>
+            <a:r>
+              <a:rPr sz="1125" b="0" dirty="0">
+                <a:solidFill>
+                  <a:srgbClr val="4B5563"/>
+                </a:solidFill>
+                <a:latin typeface="Arial"/>
+                <a:ea typeface="Arial"/>
+                <a:cs typeface="Arial"/>
+              </a:rPr>
+              <a:t> </a:t>
+            </a:r>
+            <a:r>
+              <a:rPr sz="1125" b="0" dirty="0" err="1">
+                <a:solidFill>
+                  <a:srgbClr val="4B5563"/>
+                </a:solidFill>
+                <a:latin typeface="Arial"/>
+                <a:ea typeface="Arial"/>
+                <a:cs typeface="Arial"/>
+              </a:rPr>
+              <a:t>oben</a:t>
+            </a:r>
+            <a:r>
+              <a:rPr sz="1125" b="0" dirty="0">
+                <a:solidFill>
+                  <a:srgbClr val="4B5563"/>
+                </a:solidFill>
+                <a:latin typeface="Arial"/>
+                <a:ea typeface="Arial"/>
+                <a:cs typeface="Arial"/>
+              </a:rPr>
+              <a:t> und </a:t>
+            </a:r>
+            <a:r>
+              <a:rPr sz="1125" b="0" dirty="0" err="1">
+                <a:solidFill>
+                  <a:srgbClr val="4B5563"/>
+                </a:solidFill>
+                <a:latin typeface="Arial"/>
+                <a:ea typeface="Arial"/>
+                <a:cs typeface="Arial"/>
+              </a:rPr>
+              <a:t>ist</a:t>
+            </a:r>
+            <a:r>
+              <a:rPr sz="1125" b="0" dirty="0">
+                <a:solidFill>
+                  <a:srgbClr val="4B5563"/>
+                </a:solidFill>
+                <a:latin typeface="Arial"/>
+                <a:ea typeface="Arial"/>
+                <a:cs typeface="Arial"/>
+              </a:rPr>
+              <a:t> in der </a:t>
+            </a:r>
+            <a:r>
+              <a:rPr sz="1125" b="0" dirty="0" err="1">
+                <a:solidFill>
+                  <a:srgbClr val="4B5563"/>
+                </a:solidFill>
+                <a:latin typeface="Arial"/>
+                <a:ea typeface="Arial"/>
+                <a:cs typeface="Arial"/>
+              </a:rPr>
+              <a:t>Draufsicht</a:t>
+            </a:r>
+            <a:r>
+              <a:rPr sz="1125" b="0" dirty="0">
+                <a:solidFill>
+                  <a:srgbClr val="4B5563"/>
+                </a:solidFill>
+                <a:latin typeface="Arial"/>
+                <a:ea typeface="Arial"/>
+                <a:cs typeface="Arial"/>
+              </a:rPr>
+              <a:t> nicht </a:t>
+            </a:r>
+            <a:r>
+              <a:rPr sz="1125" b="0" dirty="0" err="1">
+                <a:solidFill>
+                  <a:srgbClr val="4B5563"/>
+                </a:solidFill>
+                <a:latin typeface="Arial"/>
+                <a:ea typeface="Arial"/>
+                <a:cs typeface="Arial"/>
+              </a:rPr>
+              <a:t>dargestellt</a:t>
+            </a:r>
+            <a:r>
+              <a:rPr sz="1125" b="0" dirty="0">
+                <a:solidFill>
+                  <a:srgbClr val="4B5563"/>
+                </a:solidFill>
+                <a:latin typeface="Arial"/>
+                <a:ea typeface="Arial"/>
+                <a:cs typeface="Arial"/>
+              </a:rPr>
+              <a:t>.</a:t>
             </a:r>
           </a:p>
         </p:txBody>
       </p:sp>
+      <p:sp>
+        <p:nvSpPr>
+          <p:cNvPr id="39" name="Rechteck 38">
+            <a:extLst>
+              <a:ext uri="{FF2B5EF4-FFF2-40B4-BE49-F238E27FC236}">
+                <a16:creationId xmlns:a16="http://schemas.microsoft.com/office/drawing/2014/main" id="{B617B894-729D-4FC4-36D0-EA47523A7F62}"/>
+              </a:ext>
+            </a:extLst>
+          </p:cNvPr>
+          <p:cNvSpPr>
+            <a:spLocks noGrp="1"/>
+          </p:cNvSpPr>
+          <p:nvPr/>
+        </p:nvSpPr>
+        <p:spPr>
+          <a:xfrm>
+            <a:off x="1937865" y="3939540"/>
+            <a:ext cx="1428750" cy="285750"/>
+          </a:xfrm>
+          <a:prstGeom prst="rect">
+            <a:avLst/>
+          </a:prstGeom>
+          <a:noFill/>
+          <a:ln w="0">
+            <a:noFill/>
+          </a:ln>
+        </p:spPr>
+        <p:txBody>
+          <a:bodyPr>
+            <a:normAutofit fontScale="88452" lnSpcReduction="10000"/>
+          </a:bodyPr>
+          <a:lstStyle/>
+          <a:p>
+            <a:pPr>
+              <a:defRPr sz="1575" b="1">
+                <a:solidFill>
+                  <a:srgbClr val="17212B"/>
+                </a:solidFill>
+                <a:latin typeface="Arial"/>
+                <a:ea typeface="Arial"/>
+                <a:cs typeface="Arial"/>
+              </a:defRPr>
+            </a:pPr>
+            <a:r>
+              <a:rPr lang="de-DE" sz="1575" b="1" dirty="0">
+                <a:solidFill>
+                  <a:srgbClr val="17212B"/>
+                </a:solidFill>
+                <a:latin typeface="Arial"/>
+                <a:ea typeface="Arial"/>
+                <a:cs typeface="Arial"/>
+              </a:rPr>
+              <a:t>Griffbereich</a:t>
+            </a:r>
+            <a:endParaRPr sz="1575" b="1" dirty="0">
+              <a:solidFill>
+                <a:srgbClr val="17212B"/>
+              </a:solidFill>
+              <a:latin typeface="Arial"/>
+              <a:ea typeface="Arial"/>
+              <a:cs typeface="Arial"/>
+            </a:endParaRPr>
+          </a:p>
+        </p:txBody>
+      </p:sp>
+      <p:cxnSp>
+        <p:nvCxnSpPr>
+          <p:cNvPr id="43" name="Gerade Verbindung mit Pfeil 42">
+            <a:extLst>
+              <a:ext uri="{FF2B5EF4-FFF2-40B4-BE49-F238E27FC236}">
+                <a16:creationId xmlns:a16="http://schemas.microsoft.com/office/drawing/2014/main" id="{D44319DE-026A-0AF5-763D-791BBB12E0A5}"/>
+              </a:ext>
+            </a:extLst>
+          </p:cNvPr>
+          <p:cNvCxnSpPr>
+            <a:cxnSpLocks/>
+          </p:cNvCxnSpPr>
+          <p:nvPr/>
+        </p:nvCxnSpPr>
+        <p:spPr>
+          <a:xfrm>
+            <a:off x="1524000" y="6043522"/>
+            <a:ext cx="3996000" cy="0"/>
+          </a:xfrm>
+          <a:prstGeom prst="straightConnector1">
+            <a:avLst/>
+          </a:prstGeom>
+          <a:ln>
+            <a:headEnd type="triangle"/>
+            <a:tailEnd type="triangle"/>
+          </a:ln>
+        </p:spPr>
+        <p:style>
+          <a:lnRef idx="1">
+            <a:schemeClr val="accent1"/>
+          </a:lnRef>
+          <a:fillRef idx="0">
+            <a:schemeClr val="accent1"/>
+          </a:fillRef>
+          <a:effectRef idx="0">
+            <a:schemeClr val="accent1"/>
+          </a:effectRef>
+          <a:fontRef idx="minor">
+            <a:schemeClr val="tx1"/>
+          </a:fontRef>
+        </p:style>
+      </p:cxnSp>
+      <p:cxnSp>
+        <p:nvCxnSpPr>
+          <p:cNvPr id="45" name="Gerade Verbindung mit Pfeil 44">
+            <a:extLst>
+              <a:ext uri="{FF2B5EF4-FFF2-40B4-BE49-F238E27FC236}">
+                <a16:creationId xmlns:a16="http://schemas.microsoft.com/office/drawing/2014/main" id="{35035BCB-D284-A973-89D3-919B2AA561F3}"/>
+              </a:ext>
+            </a:extLst>
+          </p:cNvPr>
+          <p:cNvCxnSpPr>
+            <a:cxnSpLocks/>
+          </p:cNvCxnSpPr>
+          <p:nvPr/>
+        </p:nvCxnSpPr>
+        <p:spPr>
+          <a:xfrm flipV="1">
+            <a:off x="1251077" y="1819782"/>
+            <a:ext cx="0" cy="4036014"/>
+          </a:xfrm>
+          <a:prstGeom prst="straightConnector1">
+            <a:avLst/>
+          </a:prstGeom>
+          <a:ln>
+            <a:headEnd type="triangle"/>
+            <a:tailEnd type="triangle"/>
+          </a:ln>
+        </p:spPr>
+        <p:style>
+          <a:lnRef idx="1">
+            <a:schemeClr val="accent1"/>
+          </a:lnRef>
+          <a:fillRef idx="0">
+            <a:schemeClr val="accent1"/>
+          </a:fillRef>
+          <a:effectRef idx="0">
+            <a:schemeClr val="accent1"/>
+          </a:effectRef>
+          <a:fontRef idx="minor">
+            <a:schemeClr val="tx1"/>
+          </a:fontRef>
+        </p:style>
+      </p:cxnSp>
     </p:spTree>
     <p:extLst>
       <p:ext uri="{BB962C8B-B14F-4D97-AF65-F5344CB8AC3E}">
@@ -2756,7 +3891,7 @@
         </p:spPr>
         <p:txBody>
           <a:bodyPr>
-            <a:normAutofit fontScale="94792"/>
+            <a:normAutofit fontScale="94792" lnSpcReduction="10000"/>
           </a:bodyPr>
           <a:lstStyle/>
           <a:p>
@@ -2813,7 +3948,7 @@
         </p:spPr>
         <p:txBody>
           <a:bodyPr>
-            <a:normAutofit fontScale="90196"/>
+            <a:normAutofit fontScale="97696" lnSpcReduction="10000"/>
           </a:bodyPr>
           <a:lstStyle/>
           <a:p>
@@ -3169,7 +4304,7 @@
         </p:spPr>
         <p:txBody>
           <a:bodyPr>
-            <a:normAutofit fontScale="60000"/>
+            <a:normAutofit fontScale="75000" lnSpcReduction="20000"/>
           </a:bodyPr>
           <a:lstStyle/>
           <a:p>
@@ -3886,7 +5021,7 @@
               </a:defRPr>
             </a:pPr>
             <a:r>
-              <a:rPr sz="2000" b="0" dirty="0">
+              <a:rPr sz="1900" b="0" dirty="0">
                 <a:solidFill>
                   <a:srgbClr val="1D70B8"/>
                 </a:solidFill>
@@ -3915,7 +5050,7 @@
         </p:nvSpPr>
         <p:spPr>
           <a:xfrm>
-            <a:off x="609600" y="6496050"/>
+            <a:off x="609600" y="5757260"/>
             <a:ext cx="8572500" cy="190500"/>
           </a:xfrm>
           <a:prstGeom prst="rect">
@@ -3928,7 +5063,7 @@
         </p:spPr>
         <p:txBody>
           <a:bodyPr>
-            <a:normAutofit fontScale="57778"/>
+            <a:normAutofit fontScale="72778" lnSpcReduction="20000"/>
           </a:bodyPr>
           <a:lstStyle/>
           <a:p>
@@ -4000,7 +5135,7 @@
               </a:defRPr>
             </a:pPr>
             <a:r>
-              <a:rPr lang="de-DE" sz="2000" dirty="0" err="1">
+              <a:rPr lang="de-DE" sz="1900" dirty="0" err="1">
                 <a:solidFill>
                   <a:srgbClr val="1D70B8"/>
                 </a:solidFill>
@@ -4010,7 +5145,7 @@
               </a:rPr>
               <a:t>world</a:t>
             </a:r>
-            <a:endParaRPr sz="2000" b="0" dirty="0">
+            <a:endParaRPr sz="1900" b="0" dirty="0">
               <a:solidFill>
                 <a:srgbClr val="1D70B8"/>
               </a:solidFill>

</xml_diff>